<commit_message>
Replace MySQL with Iceberg as the pipeline's only store
State that lived in MySQL moves to Iceberg tables: a lease row (etl_lock) for the
single writer, a watermark derived from raw_log_landing, and etl_run_log for staleness
alerts. Writes are ordered (facts and dims first, raw rows last), commit conflicts are
retried, and etl/iceberg_maintenance.py compacts and expires snapshots. The usage
dashboard now reads from Trino. Docs and deck updated.

Co-Authored-By: Claude Sonnet 5.5 <noreply@anthropic.com>
</commit_message>
<xml_diff>
--- a/docs/SCB_Pipeline_Flow.pptx
+++ b/docs/SCB_Pipeline_Flow.pptx
@@ -3235,7 +3235,7 @@
                 </a:solidFill>
                 <a:latin typeface="Calibri"/>
               </a:rPr>
-              <a:t>End-to-end pipeline flow  |  Superset, MySQL, Trino, Iceberg</a:t>
+              <a:t>End-to-end pipeline flow  |  Superset, Trino, Iceberg</a:t>
             </a:r>
           </a:p>
         </p:txBody>
@@ -5564,7 +5564,7 @@
                 </a:solidFill>
                 <a:latin typeface="Calibri"/>
               </a:rPr>
-              <a:t>•  Schedule via Kubernetes CronJob or Airflow; alert on etl_sync_state staleness.</a:t>
+              <a:t>•  Schedule via Kubernetes CronJob (concurrencyPolicy Forbid) or Airflow; alert on etl_run_log staleness.</a:t>
             </a:r>
           </a:p>
           <a:p>
@@ -7129,7 +7129,7 @@
                 </a:solidFill>
                 <a:latin typeface="Calibri"/>
               </a:rPr>
-              <a:t>MySQL</a:t>
+              <a:t>Superset Celery</a:t>
             </a:r>
           </a:p>
           <a:p>
@@ -7141,7 +7141,7 @@
                 </a:solidFill>
                 <a:latin typeface="Calibri"/>
               </a:rPr>
-              <a:t>raw + facts + dims</a:t>
+              <a:t>worker + beat</a:t>
             </a:r>
           </a:p>
         </p:txBody>
@@ -7198,7 +7198,19 @@
                 </a:solidFill>
                 <a:latin typeface="Calibri"/>
               </a:rPr>
-              <a:t>Celery worker/beat</a:t>
+              <a:t>Bootstrap</a:t>
+            </a:r>
+          </a:p>
+          <a:p>
+            <a:pPr algn="ctr"/>
+            <a:r>
+              <a:rPr sz="1100">
+                <a:solidFill>
+                  <a:srgbClr val="5A626E"/>
+                </a:solidFill>
+                <a:latin typeface="Calibri"/>
+              </a:rPr>
+              <a:t>dashboards (one-shot)</a:t>
             </a:r>
           </a:p>
         </p:txBody>
@@ -7587,7 +7599,7 @@
                 </a:solidFill>
                 <a:latin typeface="Calibri"/>
               </a:rPr>
-              <a:t>•  ICEBERG_SINK_ENABLED switches the Iceberg path on.</a:t>
+              <a:t>•  Iceberg is the only store for the pipeline: no MySQL.</a:t>
             </a:r>
           </a:p>
           <a:p>
@@ -8605,7 +8617,7 @@
                 </a:solidFill>
                 <a:latin typeface="Calibri"/>
               </a:rPr>
-              <a:t>•  The watermark moves only after every write, including Iceberg, has succeeded.</a:t>
+              <a:t>•  Watermark = max(source_dttm) of raw_log_landing, written last, so it never gets ahead of the data.</a:t>
             </a:r>
           </a:p>
         </p:txBody>
@@ -9644,7 +9656,7 @@
                 </a:solidFill>
                 <a:latin typeface="Calibri"/>
               </a:rPr>
-              <a:t>•  A MySQL advisory lock keeps it to a single writer.</a:t>
+              <a:t>•  A lease row in Iceberg (etl_lock) keeps it to a single writer; commit conflicts are retried.</a:t>
             </a:r>
           </a:p>
           <a:p>
@@ -9660,7 +9672,7 @@
                 </a:solidFill>
                 <a:latin typeface="Calibri"/>
               </a:rPr>
-              <a:t>•  Raw JSON lands in raw_log_landing, then dims and fact tables.</a:t>
+              <a:t>•  Facts and dims are written first, raw_log_landing last; rows already stored are skipped.</a:t>
             </a:r>
           </a:p>
           <a:p>
@@ -9731,7 +9743,7 @@
                 </a:solidFill>
                 <a:latin typeface="Calibri"/>
               </a:rPr>
-              <a:t>•  --since and --full force a backfill; the watermark never moves backwards or into the future.</a:t>
+              <a:t>•  --since and --full force a backfill; future-dated rows never move the watermark.</a:t>
             </a:r>
           </a:p>
           <a:p>
@@ -11297,7 +11309,7 @@
                 </a:solidFill>
                 <a:latin typeface="Calibri"/>
               </a:rPr>
-              <a:t>dim_dashboards</a:t>
+              <a:t>raw_log_landing + dims</a:t>
             </a:r>
           </a:p>
           <a:p>
@@ -11309,7 +11321,7 @@
                 </a:solidFill>
                 <a:latin typeface="Calibri"/>
               </a:rPr>
-              <a:t>dashboard titles</a:t>
+              <a:t>raw copy, dashboards, users</a:t>
             </a:r>
           </a:p>
         </p:txBody>
@@ -11525,7 +11537,7 @@
                 </a:solidFill>
                 <a:latin typeface="Calibri"/>
               </a:rPr>
-              <a:t>•  Parquet, format v2, MERGE INTO via iceberg_sink.py (2000-row chunks).</a:t>
+              <a:t>•  Parquet, format v2, MERGE INTO via iceberg_sink.py; daily compaction and snapshot expiry.</a:t>
             </a:r>
           </a:p>
           <a:p>
@@ -12210,7 +12222,7 @@
                 </a:solidFill>
                 <a:latin typeface="Calibri"/>
               </a:rPr>
-              <a:t>•  Also: Superset Usage Analytics dashboard (MySQL) for views and users.</a:t>
+              <a:t>•  Also: Superset Usage Analytics dashboard (Iceberg) for views and users.</a:t>
             </a:r>
           </a:p>
         </p:txBody>

</xml_diff>